<commit_message>
Updated README and added artificial latency to server.py
</commit_message>
<xml_diff>
--- a/Concurrent Voice-Command ML Pipeline.pptx
+++ b/Concurrent Voice-Command ML Pipeline.pptx
@@ -335,7 +335,7 @@
               <c:strCache>
                 <c:ptCount val="1"/>
                 <c:pt idx="0">
-                  <c:v>Parallel Processing</c:v>
+                  <c:v>Sequential Processing</c:v>
                 </c:pt>
               </c:strCache>
             </c:strRef>
@@ -388,14 +388,14 @@
               <c:strCache>
                 <c:ptCount val="1"/>
                 <c:pt idx="0">
-                  <c:v>Sequential Processing</c:v>
+                  <c:v>Parallel Processing</c:v>
                 </c:pt>
               </c:strCache>
             </c:strRef>
           </c:tx>
           <c:spPr>
             <a:solidFill>
-              <a:schemeClr val="accent2"/>
+              <a:srgbClr val="08524D"/>
             </a:solidFill>
             <a:ln>
               <a:noFill/>
@@ -4068,7 +4068,7 @@
               </a:spcAft>
               <a:buNone/>
             </a:pPr>
-            <a:endParaRPr/>
+            <a:endParaRPr dirty="0"/>
           </a:p>
         </p:txBody>
       </p:sp>
@@ -14320,6 +14320,55 @@
           <a:chExt cx="0" cy="0"/>
         </a:xfrm>
       </p:grpSpPr>
+      <p:sp>
+        <p:nvSpPr>
+          <p:cNvPr id="2" name="Rectangle 1">
+            <a:extLst>
+              <a:ext uri="{FF2B5EF4-FFF2-40B4-BE49-F238E27FC236}">
+                <a16:creationId xmlns:a16="http://schemas.microsoft.com/office/drawing/2014/main" id="{30387983-D61D-B806-AE87-76AADDCD09CE}"/>
+              </a:ext>
+            </a:extLst>
+          </p:cNvPr>
+          <p:cNvSpPr/>
+          <p:nvPr/>
+        </p:nvSpPr>
+        <p:spPr>
+          <a:xfrm>
+            <a:off x="0" y="0"/>
+            <a:ext cx="18287996" cy="7318570"/>
+          </a:xfrm>
+          <a:prstGeom prst="rect">
+            <a:avLst/>
+          </a:prstGeom>
+          <a:solidFill>
+            <a:schemeClr val="bg1"/>
+          </a:solidFill>
+        </p:spPr>
+        <p:style>
+          <a:lnRef idx="2">
+            <a:schemeClr val="accent1">
+              <a:shade val="50000"/>
+            </a:schemeClr>
+          </a:lnRef>
+          <a:fillRef idx="1">
+            <a:schemeClr val="accent1"/>
+          </a:fillRef>
+          <a:effectRef idx="0">
+            <a:schemeClr val="accent1"/>
+          </a:effectRef>
+          <a:fontRef idx="minor">
+            <a:schemeClr val="lt1"/>
+          </a:fontRef>
+        </p:style>
+        <p:txBody>
+          <a:bodyPr rtlCol="0" anchor="ctr"/>
+          <a:lstStyle/>
+          <a:p>
+            <a:pPr algn="ctr"/>
+            <a:endParaRPr lang="en-US"/>
+          </a:p>
+        </p:txBody>
+      </p:sp>
       <p:grpSp>
         <p:nvGrpSpPr>
           <p:cNvPr id="184" name="Google Shape;184;p11"/>
@@ -14547,8 +14596,8 @@
         </p:nvSpPr>
         <p:spPr>
           <a:xfrm>
-            <a:off x="0" y="-30763"/>
-            <a:ext cx="5103552" cy="7318570"/>
+            <a:off x="331534" y="157703"/>
+            <a:ext cx="4772018" cy="7033929"/>
           </a:xfrm>
           <a:prstGeom prst="rect">
             <a:avLst/>
@@ -14866,8 +14915,8 @@
         </p:blipFill>
         <p:spPr>
           <a:xfrm>
-            <a:off x="5103556" y="-61527"/>
-            <a:ext cx="13184440" cy="7349334"/>
+            <a:off x="5544456" y="253878"/>
+            <a:ext cx="12743539" cy="7033928"/>
           </a:xfrm>
           <a:prstGeom prst="rect">
             <a:avLst/>
@@ -16405,7 +16454,7 @@
         <p:spPr>
           <a:xfrm>
             <a:off x="6014077" y="7775425"/>
-            <a:ext cx="2412300" cy="1477328"/>
+            <a:ext cx="2412300" cy="1846659"/>
           </a:xfrm>
           <a:prstGeom prst="rect">
             <a:avLst/>
@@ -16464,7 +16513,7 @@
                 <a:ea typeface="Lato"/>
                 <a:cs typeface="Lato"/>
               </a:rPr>
-              <a:t> to mathematically map audio into a 40x32 feature matrix.</a:t>
+              <a:t> to mathematically map audio into a 40x32 cepstral coefficients matrix.</a:t>
             </a:r>
             <a:endParaRPr sz="2000" dirty="0">
               <a:solidFill>
@@ -16523,7 +16572,7 @@
                 <a:ea typeface="Lato"/>
                 <a:cs typeface="Lato"/>
               </a:rPr>
-              <a:t>Custom architecture trained from scratch on 19,000 balanced files.</a:t>
+              <a:t>Custom architecture trained from scratch on 19,000 files.</a:t>
             </a:r>
             <a:endParaRPr sz="2000" dirty="0">
               <a:solidFill>
@@ -17102,7 +17151,7 @@
         </p:nvSpPr>
         <p:spPr>
           <a:xfrm>
-            <a:off x="765546" y="2422331"/>
+            <a:off x="765546" y="2575633"/>
             <a:ext cx="2506543" cy="1207703"/>
           </a:xfrm>
           <a:prstGeom prst="rect">
@@ -17154,7 +17203,7 @@
         </p:nvSpPr>
         <p:spPr>
           <a:xfrm>
-            <a:off x="1016328" y="6888230"/>
+            <a:off x="962013" y="6737062"/>
             <a:ext cx="2113608" cy="1207703"/>
           </a:xfrm>
           <a:prstGeom prst="rect">
@@ -17327,7 +17376,7 @@
         <p:spPr>
           <a:xfrm>
             <a:off x="8224694" y="1371601"/>
-            <a:ext cx="10063306" cy="8915400"/>
+            <a:ext cx="9651171" cy="8550277"/>
           </a:xfrm>
           <a:prstGeom prst="rect">
             <a:avLst/>
@@ -18232,7 +18281,7 @@
         </p:nvSpPr>
         <p:spPr>
           <a:xfrm>
-            <a:off x="-5" y="0"/>
+            <a:off x="14509" y="0"/>
             <a:ext cx="18288005" cy="7365463"/>
           </a:xfrm>
           <a:prstGeom prst="rect">
@@ -18272,60 +18321,6 @@
           </a:p>
         </p:txBody>
       </p:sp>
-      <p:sp>
-        <p:nvSpPr>
-          <p:cNvPr id="11" name="Rectangle 10">
-            <a:extLst>
-              <a:ext uri="{FF2B5EF4-FFF2-40B4-BE49-F238E27FC236}">
-                <a16:creationId xmlns:a16="http://schemas.microsoft.com/office/drawing/2014/main" id="{084877CA-7889-33B4-CBD9-6279CEC7E50E}"/>
-              </a:ext>
-            </a:extLst>
-          </p:cNvPr>
-          <p:cNvSpPr/>
-          <p:nvPr/>
-        </p:nvSpPr>
-        <p:spPr>
-          <a:xfrm>
-            <a:off x="0" y="0"/>
-            <a:ext cx="6042212" cy="7318571"/>
-          </a:xfrm>
-          <a:prstGeom prst="rect">
-            <a:avLst/>
-          </a:prstGeom>
-          <a:solidFill>
-            <a:srgbClr val="08524D"/>
-          </a:solidFill>
-          <a:ln>
-            <a:solidFill>
-              <a:srgbClr val="08524D"/>
-            </a:solidFill>
-          </a:ln>
-        </p:spPr>
-        <p:style>
-          <a:lnRef idx="2">
-            <a:schemeClr val="accent1">
-              <a:shade val="50000"/>
-            </a:schemeClr>
-          </a:lnRef>
-          <a:fillRef idx="1">
-            <a:schemeClr val="accent1"/>
-          </a:fillRef>
-          <a:effectRef idx="0">
-            <a:schemeClr val="accent1"/>
-          </a:effectRef>
-          <a:fontRef idx="minor">
-            <a:schemeClr val="lt1"/>
-          </a:fontRef>
-        </p:style>
-        <p:txBody>
-          <a:bodyPr rtlCol="0" anchor="ctr"/>
-          <a:lstStyle/>
-          <a:p>
-            <a:pPr algn="ctr"/>
-            <a:endParaRPr lang="en-US"/>
-          </a:p>
-        </p:txBody>
-      </p:sp>
       <p:grpSp>
         <p:nvGrpSpPr>
           <p:cNvPr id="332" name="Google Shape;332;p16"/>
@@ -18334,7 +18329,7 @@
         </p:nvGrpSpPr>
         <p:grpSpPr>
           <a:xfrm>
-            <a:off x="-5" y="6993084"/>
+            <a:off x="-5" y="7036627"/>
             <a:ext cx="18288000" cy="3293916"/>
             <a:chOff x="0" y="-85725"/>
             <a:chExt cx="4816593" cy="867533"/>
@@ -18420,7 +18415,7 @@
                 </a:spcAft>
                 <a:buNone/>
               </a:pPr>
-              <a:endParaRPr sz="1800" b="0" i="0" u="none" strike="noStrike" cap="none">
+              <a:endParaRPr sz="1800" b="0" i="0" u="none" strike="noStrike" cap="none" dirty="0">
                 <a:solidFill>
                   <a:schemeClr val="dk1"/>
                 </a:solidFill>
@@ -18550,7 +18545,7 @@
           <p:nvPr>
             <p:extLst>
               <p:ext uri="{D42A27DB-BD31-4B8C-83A1-F6EECF244321}">
-                <p14:modId xmlns:p14="http://schemas.microsoft.com/office/powerpoint/2010/main" val="682661822"/>
+                <p14:modId xmlns:p14="http://schemas.microsoft.com/office/powerpoint/2010/main" val="4035857053"/>
               </p:ext>
             </p:extLst>
           </p:nvPr>
@@ -18579,7 +18574,7 @@
         </p:nvSpPr>
         <p:spPr>
           <a:xfrm>
-            <a:off x="451886" y="1697862"/>
+            <a:off x="520125" y="1312851"/>
             <a:ext cx="5034514" cy="4739759"/>
           </a:xfrm>
           <a:prstGeom prst="rect">
@@ -18615,7 +18610,7 @@
                   <a:noFill/>
                 </a:ln>
                 <a:solidFill>
-                  <a:schemeClr val="bg1"/>
+                  <a:srgbClr val="08524D"/>
                 </a:solidFill>
                 <a:effectLst/>
                 <a:latin typeface="Lato" panose="020F0502020204030203" pitchFamily="34" charset="0"/>
@@ -18644,7 +18639,7 @@
             </a:pPr>
             <a:endParaRPr lang="en-US" altLang="en-US" sz="3200" dirty="0">
               <a:solidFill>
-                <a:schemeClr val="bg1"/>
+                <a:srgbClr val="08524D"/>
               </a:solidFill>
               <a:latin typeface="Lato" panose="020F0502020204030203" pitchFamily="34" charset="0"/>
               <a:ea typeface="Lato" panose="020F0502020204030203" pitchFamily="34" charset="0"/>
@@ -18673,7 +18668,7 @@
                 <a:noFill/>
               </a:ln>
               <a:solidFill>
-                <a:schemeClr val="bg1"/>
+                <a:srgbClr val="08524D"/>
               </a:solidFill>
               <a:effectLst/>
               <a:latin typeface="Lato" panose="020F0502020204030203" pitchFamily="34" charset="0"/>
@@ -18704,7 +18699,7 @@
                   <a:noFill/>
                 </a:ln>
                 <a:solidFill>
-                  <a:schemeClr val="bg1"/>
+                  <a:srgbClr val="08524D"/>
                 </a:solidFill>
                 <a:effectLst/>
                 <a:latin typeface="Lato" panose="020F0502020204030203" pitchFamily="34" charset="0"/>
@@ -18733,7 +18728,7 @@
             </a:pPr>
             <a:endParaRPr lang="en-US" altLang="en-US" sz="3200" dirty="0">
               <a:solidFill>
-                <a:schemeClr val="bg1"/>
+                <a:srgbClr val="08524D"/>
               </a:solidFill>
               <a:latin typeface="Lato" panose="020F0502020204030203" pitchFamily="34" charset="0"/>
               <a:ea typeface="Lato" panose="020F0502020204030203" pitchFamily="34" charset="0"/>
@@ -18762,7 +18757,7 @@
                 <a:noFill/>
               </a:ln>
               <a:solidFill>
-                <a:schemeClr val="bg1"/>
+                <a:srgbClr val="08524D"/>
               </a:solidFill>
               <a:effectLst/>
               <a:latin typeface="Lato" panose="020F0502020204030203" pitchFamily="34" charset="0"/>
@@ -18787,6 +18782,21 @@
               <a:buChar char="•"/>
               <a:tabLst/>
             </a:pPr>
+            <a:r>
+              <a:rPr kumimoji="0" lang="en-US" altLang="en-US" sz="3200" i="0" u="none" strike="noStrike" cap="none" normalizeH="0" baseline="0" dirty="0">
+                <a:ln>
+                  <a:noFill/>
+                </a:ln>
+                <a:solidFill>
+                  <a:srgbClr val="08524D"/>
+                </a:solidFill>
+                <a:effectLst/>
+                <a:latin typeface="Lato" panose="020F0502020204030203" pitchFamily="34" charset="0"/>
+                <a:ea typeface="Lato" panose="020F0502020204030203" pitchFamily="34" charset="0"/>
+                <a:cs typeface="Lato" panose="020F0502020204030203" pitchFamily="34" charset="0"/>
+              </a:rPr>
+              <a:t>Speedup Factor</a:t>
+            </a:r>
             <a:r>
               <a:rPr kumimoji="0" lang="en-US" altLang="en-US" sz="3200" i="0" u="none" strike="noStrike" cap="none" normalizeH="0" baseline="0" dirty="0">
                 <a:ln>
@@ -18800,7 +18810,22 @@
                 <a:ea typeface="Lato" panose="020F0502020204030203" pitchFamily="34" charset="0"/>
                 <a:cs typeface="Lato" panose="020F0502020204030203" pitchFamily="34" charset="0"/>
               </a:rPr>
-              <a:t>Speedup Factor: 6.05x</a:t>
+              <a:t>: </a:t>
+            </a:r>
+            <a:r>
+              <a:rPr kumimoji="0" lang="en-US" altLang="en-US" sz="3200" i="0" u="none" strike="noStrike" cap="none" normalizeH="0" baseline="0" dirty="0">
+                <a:ln>
+                  <a:noFill/>
+                </a:ln>
+                <a:solidFill>
+                  <a:srgbClr val="08524D"/>
+                </a:solidFill>
+                <a:effectLst/>
+                <a:latin typeface="Lato" panose="020F0502020204030203" pitchFamily="34" charset="0"/>
+                <a:ea typeface="Lato" panose="020F0502020204030203" pitchFamily="34" charset="0"/>
+                <a:cs typeface="Lato" panose="020F0502020204030203" pitchFamily="34" charset="0"/>
+              </a:rPr>
+              <a:t>6.05x</a:t>
             </a:r>
           </a:p>
           <a:p>
@@ -20034,13 +20059,15 @@
               </a:ext>
             </a:extLst>
           </p:cNvPr>
-          <p:cNvCxnSpPr/>
+          <p:cNvCxnSpPr>
+            <a:cxnSpLocks/>
+          </p:cNvCxnSpPr>
           <p:nvPr/>
         </p:nvCxnSpPr>
         <p:spPr>
           <a:xfrm>
-            <a:off x="10387263" y="2791326"/>
-            <a:ext cx="7620000" cy="0"/>
+            <a:off x="10285663" y="2850744"/>
+            <a:ext cx="7668508" cy="0"/>
           </a:xfrm>
           <a:prstGeom prst="line">
             <a:avLst/>
@@ -20161,8 +20188,8 @@
         </p:nvCxnSpPr>
         <p:spPr>
           <a:xfrm flipV="1">
-            <a:off x="14197263" y="2064513"/>
-            <a:ext cx="1803704" cy="678687"/>
+            <a:off x="14193672" y="2064513"/>
+            <a:ext cx="1807295" cy="786231"/>
           </a:xfrm>
           <a:prstGeom prst="straightConnector1">
             <a:avLst/>
@@ -22372,7 +22399,7 @@
           <p:nvPr>
             <p:extLst>
               <p:ext uri="{D42A27DB-BD31-4B8C-83A1-F6EECF244321}">
-                <p14:modId xmlns:p14="http://schemas.microsoft.com/office/powerpoint/2010/main" val="663063711"/>
+                <p14:modId xmlns:p14="http://schemas.microsoft.com/office/powerpoint/2010/main" val="2582691307"/>
               </p:ext>
             </p:extLst>
           </p:nvPr>
@@ -22752,9 +22779,6 @@
                         </a:rPr>
                         <a:t>};</a:t>
                       </a:r>
-                    </a:p>
-                    <a:p>
-                      <a:endParaRPr lang="en-US" dirty="0"/>
                     </a:p>
                   </a:txBody>
                   <a:tcPr>

</xml_diff>